<commit_message>
Remove ServiceLink from all deliverables (whitepaper, deck, data dictionary, PDFs)
</commit_message>
<xml_diff>
--- a/deliverables/GSE_Foreclosure_Deck.pptx
+++ b/deliverables/GSE_Foreclosure_Deck.pptx
@@ -2401,6 +2401,10 @@
             <a:prstDash val="solid"/>
           </a:ln>
         </p:spPr>
+        <p:txBody>
+          <a:bodyPr/>
+          <a:p/>
+        </p:txBody>
       </p:sp>
       <p:sp>
         <p:nvSpPr>
@@ -2474,7 +2478,7 @@
                 <a:ea typeface="Calibri" pitchFamily="34" charset="-122"/>
                 <a:cs typeface="Calibri" pitchFamily="34" charset="-120"/>
               </a:rPr>
-              <a:t>Prepared for</a:t>
+              <a:t/>
             </a:r>
             <a:endParaRPr lang="en-US" sz="1100" dirty="0"/>
           </a:p>
@@ -2513,7 +2517,7 @@
                 <a:ea typeface="Calibri" pitchFamily="34" charset="-122"/>
                 <a:cs typeface="Calibri" pitchFamily="34" charset="-120"/>
               </a:rPr>
-              <a:t>ServiceLink</a:t>
+              <a:t/>
             </a:r>
             <a:endParaRPr lang="en-US" sz="2200" dirty="0"/>
           </a:p>
@@ -2690,6 +2694,10 @@
             <a:prstDash val="solid"/>
           </a:ln>
         </p:spPr>
+        <p:txBody>
+          <a:bodyPr/>
+          <a:p/>
+        </p:txBody>
       </p:sp>
       <p:sp>
         <p:nvSpPr>
@@ -2817,6 +2825,10 @@
             <a:prstDash val="solid"/>
           </a:ln>
         </p:spPr>
+        <p:txBody>
+          <a:bodyPr/>
+          <a:p/>
+        </p:txBody>
       </p:sp>
       <p:sp>
         <p:nvSpPr>
@@ -2943,7 +2955,7 @@
                 <a:ea typeface="Calibri" pitchFamily="34" charset="-122"/>
                 <a:cs typeface="Calibri" pitchFamily="34" charset="-120"/>
               </a:rPr>
-              <a:t>GSE Foreclosure Analysis  |  ServiceLink  |  April 2026</a:t>
+              <a:t>GSE Foreclosure Analysis  |  April 2026</a:t>
             </a:r>
             <a:endParaRPr lang="en-US" sz="1000" dirty="0"/>
           </a:p>
@@ -3081,6 +3093,10 @@
             <a:prstDash val="solid"/>
           </a:ln>
         </p:spPr>
+        <p:txBody>
+          <a:bodyPr/>
+          <a:p/>
+        </p:txBody>
       </p:sp>
       <p:sp>
         <p:nvSpPr>
@@ -3106,6 +3122,10 @@
             <a:prstDash val="solid"/>
           </a:ln>
         </p:spPr>
+        <p:txBody>
+          <a:bodyPr/>
+          <a:p/>
+        </p:txBody>
       </p:sp>
       <p:sp>
         <p:nvSpPr>
@@ -3248,6 +3268,10 @@
             <a:prstDash val="solid"/>
           </a:ln>
         </p:spPr>
+        <p:txBody>
+          <a:bodyPr/>
+          <a:p/>
+        </p:txBody>
       </p:sp>
       <p:sp>
         <p:nvSpPr>
@@ -3390,6 +3414,10 @@
             <a:prstDash val="solid"/>
           </a:ln>
         </p:spPr>
+        <p:txBody>
+          <a:bodyPr/>
+          <a:p/>
+        </p:txBody>
       </p:sp>
       <p:sp>
         <p:nvSpPr>
@@ -3532,6 +3560,10 @@
             <a:prstDash val="solid"/>
           </a:ln>
         </p:spPr>
+        <p:txBody>
+          <a:bodyPr/>
+          <a:p/>
+        </p:txBody>
       </p:sp>
       <p:sp>
         <p:nvSpPr>
@@ -3605,7 +3637,7 @@
                 <a:ea typeface="Calibri" pitchFamily="34" charset="-122"/>
                 <a:cs typeface="Calibri" pitchFamily="34" charset="-120"/>
               </a:rPr>
-              <a:t>GSE data does not record actual auction venue. Our online-vs-offline test uses state-level platform-adoption tiers as a proxy. To test venue rigorously requires ServiceLink-internal auction-venue records joined to disposition outcomes — a 4-6 week analytical project.</a:t>
+              <a:t>GSE data does not record actual auction venue. Our online-vs-offline test uses state-level platform-adoption tiers as a proxy. To test venue rigorously requires -internal auction-venue records joined to disposition outcomes — a 4-6 week analytical project.</a:t>
             </a:r>
             <a:endParaRPr lang="en-US" sz="1200" dirty="0"/>
           </a:p>
@@ -3683,7 +3715,7 @@
                 <a:ea typeface="Calibri" pitchFamily="34" charset="-122"/>
                 <a:cs typeface="Calibri" pitchFamily="34" charset="-120"/>
               </a:rPr>
-              <a:t>GSE Foreclosure Analysis  |  ServiceLink  |  April 2026</a:t>
+              <a:t>GSE Foreclosure Analysis  |  April 2026</a:t>
             </a:r>
             <a:endParaRPr lang="en-US" sz="1000" dirty="0"/>
           </a:p>
@@ -3821,6 +3853,10 @@
             <a:prstDash val="solid"/>
           </a:ln>
         </p:spPr>
+        <p:txBody>
+          <a:bodyPr/>
+          <a:p/>
+        </p:txBody>
       </p:sp>
       <p:pic>
         <p:nvPicPr>
@@ -4205,7 +4241,7 @@
                 <a:ea typeface="Calibri" pitchFamily="34" charset="-122"/>
                 <a:cs typeface="Calibri" pitchFamily="34" charset="-120"/>
               </a:rPr>
-              <a:t>$65K/REO holding cost · 200K US GSE foreclosures/yr · 30% ServiceLink share · 84% bottom-decile REO rate. Replace with internal numbers before commitment.</a:t>
+              <a:t>$65K/REO holding cost · 200K US GSE foreclosures/yr · 30%  share · 84% bottom-decile REO rate. Replace with internal numbers before commitment.</a:t>
             </a:r>
             <a:endParaRPr lang="en-US" sz="1000" dirty="0"/>
           </a:p>
@@ -4283,7 +4319,7 @@
                 <a:ea typeface="Calibri" pitchFamily="34" charset="-122"/>
                 <a:cs typeface="Calibri" pitchFamily="34" charset="-120"/>
               </a:rPr>
-              <a:t>GSE Foreclosure Analysis  |  ServiceLink  |  April 2026</a:t>
+              <a:t>GSE Foreclosure Analysis  |  April 2026</a:t>
             </a:r>
             <a:endParaRPr lang="en-US" sz="1000" dirty="0"/>
           </a:p>
@@ -4421,6 +4457,10 @@
             <a:prstDash val="solid"/>
           </a:ln>
         </p:spPr>
+        <p:txBody>
+          <a:bodyPr/>
+          <a:p/>
+        </p:txBody>
       </p:sp>
       <p:pic>
         <p:nvPicPr>
@@ -4696,6 +4736,10 @@
             <a:prstDash val="solid"/>
           </a:ln>
         </p:spPr>
+        <p:txBody>
+          <a:bodyPr/>
+          <a:p/>
+        </p:txBody>
       </p:sp>
       <p:sp>
         <p:nvSpPr>
@@ -4847,7 +4891,7 @@
                 <a:ea typeface="Calibri" pitchFamily="34" charset="-122"/>
                 <a:cs typeface="Calibri" pitchFamily="34" charset="-120"/>
               </a:rPr>
-              <a:t>GSE Foreclosure Analysis  |  ServiceLink  |  April 2026</a:t>
+              <a:t>GSE Foreclosure Analysis  |  April 2026</a:t>
             </a:r>
             <a:endParaRPr lang="en-US" sz="1000" dirty="0"/>
           </a:p>
@@ -4985,6 +5029,10 @@
             <a:prstDash val="solid"/>
           </a:ln>
         </p:spPr>
+        <p:txBody>
+          <a:bodyPr/>
+          <a:p/>
+        </p:txBody>
       </p:sp>
       <p:sp>
         <p:nvSpPr>
@@ -5010,6 +5058,10 @@
             <a:prstDash val="solid"/>
           </a:ln>
         </p:spPr>
+        <p:txBody>
+          <a:bodyPr/>
+          <a:p/>
+        </p:txBody>
       </p:sp>
       <p:sp>
         <p:nvSpPr>
@@ -5400,6 +5452,10 @@
             <a:prstDash val="solid"/>
           </a:ln>
         </p:spPr>
+        <p:txBody>
+          <a:bodyPr/>
+          <a:p/>
+        </p:txBody>
       </p:sp>
       <p:sp>
         <p:nvSpPr>
@@ -5838,7 +5894,7 @@
                 <a:ea typeface="Calibri" pitchFamily="34" charset="-122"/>
                 <a:cs typeface="Calibri" pitchFamily="34" charset="-120"/>
               </a:rPr>
-              <a:t>GSE Foreclosure Analysis  |  ServiceLink  |  April 2026</a:t>
+              <a:t>GSE Foreclosure Analysis  |  April 2026</a:t>
             </a:r>
             <a:endParaRPr lang="en-US" sz="1000" dirty="0"/>
           </a:p>
@@ -5976,6 +6032,10 @@
             <a:prstDash val="solid"/>
           </a:ln>
         </p:spPr>
+        <p:txBody>
+          <a:bodyPr/>
+          <a:p/>
+        </p:txBody>
       </p:sp>
       <p:sp>
         <p:nvSpPr>
@@ -6040,6 +6100,10 @@
             <a:prstDash val="solid"/>
           </a:ln>
         </p:spPr>
+        <p:txBody>
+          <a:bodyPr/>
+          <a:p/>
+        </p:txBody>
       </p:sp>
       <p:sp>
         <p:nvSpPr>
@@ -6429,6 +6493,10 @@
             <a:prstDash val="solid"/>
           </a:ln>
         </p:spPr>
+        <p:txBody>
+          <a:bodyPr/>
+          <a:p/>
+        </p:txBody>
       </p:sp>
       <p:sp>
         <p:nvSpPr>
@@ -6919,7 +6987,7 @@
                 <a:ea typeface="Calibri" pitchFamily="34" charset="-122"/>
                 <a:cs typeface="Calibri" pitchFamily="34" charset="-120"/>
               </a:rPr>
-              <a:t>GSE Foreclosure Analysis  |  ServiceLink  |  April 2026</a:t>
+              <a:t>GSE Foreclosure Analysis  |  April 2026</a:t>
             </a:r>
             <a:endParaRPr lang="en-US" sz="1000" dirty="0"/>
           </a:p>
@@ -7057,6 +7125,10 @@
             <a:prstDash val="solid"/>
           </a:ln>
         </p:spPr>
+        <p:txBody>
+          <a:bodyPr/>
+          <a:p/>
+        </p:txBody>
       </p:sp>
       <p:sp>
         <p:nvSpPr>
@@ -7082,6 +7154,10 @@
             <a:prstDash val="solid"/>
           </a:ln>
         </p:spPr>
+        <p:txBody>
+          <a:bodyPr/>
+          <a:p/>
+        </p:txBody>
       </p:sp>
       <p:sp>
         <p:nvSpPr>
@@ -7270,6 +7346,10 @@
             <a:prstDash val="solid"/>
           </a:ln>
         </p:spPr>
+        <p:txBody>
+          <a:bodyPr/>
+          <a:p/>
+        </p:txBody>
       </p:sp>
       <p:sp>
         <p:nvSpPr>
@@ -7458,6 +7538,10 @@
             <a:prstDash val="solid"/>
           </a:ln>
         </p:spPr>
+        <p:txBody>
+          <a:bodyPr/>
+          <a:p/>
+        </p:txBody>
       </p:sp>
       <p:sp>
         <p:nvSpPr>
@@ -7694,7 +7778,7 @@
                 <a:ea typeface="Calibri" pitchFamily="34" charset="-122"/>
                 <a:cs typeface="Calibri" pitchFamily="34" charset="-120"/>
               </a:rPr>
-              <a:t>GSE Foreclosure Analysis  |  ServiceLink  |  April 2026</a:t>
+              <a:t>GSE Foreclosure Analysis  |  April 2026</a:t>
             </a:r>
             <a:endParaRPr lang="en-US" sz="1000" dirty="0"/>
           </a:p>
@@ -7795,6 +7879,10 @@
             <a:prstDash val="solid"/>
           </a:ln>
         </p:spPr>
+        <p:txBody>
+          <a:bodyPr/>
+          <a:p/>
+        </p:txBody>
       </p:sp>
       <p:sp>
         <p:nvSpPr>
@@ -8396,6 +8484,10 @@
             <a:prstDash val="solid"/>
           </a:ln>
         </p:spPr>
+        <p:txBody>
+          <a:bodyPr/>
+          <a:p/>
+        </p:txBody>
       </p:sp>
       <p:sp>
         <p:nvSpPr>
@@ -8421,6 +8513,10 @@
             <a:prstDash val="solid"/>
           </a:ln>
         </p:spPr>
+        <p:txBody>
+          <a:bodyPr/>
+          <a:p/>
+        </p:txBody>
       </p:sp>
       <p:sp>
         <p:nvSpPr>
@@ -8524,6 +8620,10 @@
             <a:prstDash val="solid"/>
           </a:ln>
         </p:spPr>
+        <p:txBody>
+          <a:bodyPr/>
+          <a:p/>
+        </p:txBody>
       </p:sp>
       <p:sp>
         <p:nvSpPr>
@@ -8627,6 +8727,10 @@
             <a:prstDash val="solid"/>
           </a:ln>
         </p:spPr>
+        <p:txBody>
+          <a:bodyPr/>
+          <a:p/>
+        </p:txBody>
       </p:sp>
       <p:sp>
         <p:nvSpPr>
@@ -8730,6 +8834,10 @@
             <a:prstDash val="solid"/>
           </a:ln>
         </p:spPr>
+        <p:txBody>
+          <a:bodyPr/>
+          <a:p/>
+        </p:txBody>
       </p:sp>
       <p:sp>
         <p:nvSpPr>
@@ -8872,6 +8980,10 @@
             <a:prstDash val="solid"/>
           </a:ln>
         </p:spPr>
+        <p:txBody>
+          <a:bodyPr/>
+          <a:p/>
+        </p:txBody>
       </p:sp>
       <p:sp>
         <p:nvSpPr>
@@ -9014,6 +9126,10 @@
             <a:prstDash val="solid"/>
           </a:ln>
         </p:spPr>
+        <p:txBody>
+          <a:bodyPr/>
+          <a:p/>
+        </p:txBody>
       </p:sp>
       <p:sp>
         <p:nvSpPr>
@@ -9204,7 +9320,7 @@
                 <a:ea typeface="Calibri" pitchFamily="34" charset="-122"/>
                 <a:cs typeface="Calibri" pitchFamily="34" charset="-120"/>
               </a:rPr>
-              <a:t>GSE Foreclosure Analysis  |  ServiceLink  |  April 2026</a:t>
+              <a:t>GSE Foreclosure Analysis  |  April 2026</a:t>
             </a:r>
             <a:endParaRPr lang="en-US" sz="1000" dirty="0"/>
           </a:p>
@@ -9342,6 +9458,10 @@
             <a:prstDash val="solid"/>
           </a:ln>
         </p:spPr>
+        <p:txBody>
+          <a:bodyPr/>
+          <a:p/>
+        </p:txBody>
       </p:sp>
       <p:sp>
         <p:nvSpPr>
@@ -9406,6 +9526,10 @@
             <a:prstDash val="solid"/>
           </a:ln>
         </p:spPr>
+        <p:txBody>
+          <a:bodyPr/>
+          <a:p/>
+        </p:txBody>
       </p:sp>
       <p:sp>
         <p:nvSpPr>
@@ -9548,6 +9672,10 @@
             <a:prstDash val="solid"/>
           </a:ln>
         </p:spPr>
+        <p:txBody>
+          <a:bodyPr/>
+          <a:p/>
+        </p:txBody>
       </p:sp>
       <p:sp>
         <p:nvSpPr>
@@ -9690,6 +9818,10 @@
             <a:prstDash val="solid"/>
           </a:ln>
         </p:spPr>
+        <p:txBody>
+          <a:bodyPr/>
+          <a:p/>
+        </p:txBody>
       </p:sp>
       <p:sp>
         <p:nvSpPr>
@@ -9841,7 +9973,7 @@
                 <a:ea typeface="Calibri" pitchFamily="34" charset="-122"/>
                 <a:cs typeface="Calibri" pitchFamily="34" charset="-120"/>
               </a:rPr>
-              <a:t>GSE Foreclosure Analysis  |  ServiceLink  |  April 2026</a:t>
+              <a:t>GSE Foreclosure Analysis  |  April 2026</a:t>
             </a:r>
             <a:endParaRPr lang="en-US" sz="1000" dirty="0"/>
           </a:p>
@@ -9979,6 +10111,10 @@
             <a:prstDash val="solid"/>
           </a:ln>
         </p:spPr>
+        <p:txBody>
+          <a:bodyPr/>
+          <a:p/>
+        </p:txBody>
       </p:sp>
       <p:sp>
         <p:nvSpPr>
@@ -10583,7 +10719,7 @@
                 <a:ea typeface="Calibri" pitchFamily="34" charset="-122"/>
                 <a:cs typeface="Calibri" pitchFamily="34" charset="-120"/>
               </a:rPr>
-              <a:t>GSE Foreclosure Analysis  |  ServiceLink  |  April 2026</a:t>
+              <a:t>GSE Foreclosure Analysis  |  April 2026</a:t>
             </a:r>
             <a:endParaRPr lang="en-US" sz="1000" dirty="0"/>
           </a:p>
@@ -10721,6 +10857,10 @@
             <a:prstDash val="solid"/>
           </a:ln>
         </p:spPr>
+        <p:txBody>
+          <a:bodyPr/>
+          <a:p/>
+        </p:txBody>
       </p:sp>
       <p:sp>
         <p:nvSpPr>
@@ -10785,6 +10925,10 @@
             <a:prstDash val="solid"/>
           </a:ln>
         </p:spPr>
+        <p:txBody>
+          <a:bodyPr/>
+          <a:p/>
+        </p:txBody>
       </p:sp>
       <p:sp>
         <p:nvSpPr>
@@ -10810,6 +10954,10 @@
             <a:prstDash val="solid"/>
           </a:ln>
         </p:spPr>
+        <p:txBody>
+          <a:bodyPr/>
+          <a:p/>
+        </p:txBody>
       </p:sp>
       <p:sp>
         <p:nvSpPr>
@@ -10952,6 +11100,10 @@
             <a:prstDash val="solid"/>
           </a:ln>
         </p:spPr>
+        <p:txBody>
+          <a:bodyPr/>
+          <a:p/>
+        </p:txBody>
       </p:sp>
       <p:sp>
         <p:nvSpPr>
@@ -10977,6 +11129,10 @@
             <a:prstDash val="solid"/>
           </a:ln>
         </p:spPr>
+        <p:txBody>
+          <a:bodyPr/>
+          <a:p/>
+        </p:txBody>
       </p:sp>
       <p:sp>
         <p:nvSpPr>
@@ -11119,6 +11275,10 @@
             <a:prstDash val="solid"/>
           </a:ln>
         </p:spPr>
+        <p:txBody>
+          <a:bodyPr/>
+          <a:p/>
+        </p:txBody>
       </p:sp>
       <p:sp>
         <p:nvSpPr>
@@ -11144,6 +11304,10 @@
             <a:prstDash val="solid"/>
           </a:ln>
         </p:spPr>
+        <p:txBody>
+          <a:bodyPr/>
+          <a:p/>
+        </p:txBody>
       </p:sp>
       <p:sp>
         <p:nvSpPr>
@@ -11286,6 +11450,10 @@
             <a:prstDash val="solid"/>
           </a:ln>
         </p:spPr>
+        <p:txBody>
+          <a:bodyPr/>
+          <a:p/>
+        </p:txBody>
       </p:sp>
       <p:sp>
         <p:nvSpPr>
@@ -11311,6 +11479,10 @@
             <a:prstDash val="solid"/>
           </a:ln>
         </p:spPr>
+        <p:txBody>
+          <a:bodyPr/>
+          <a:p/>
+        </p:txBody>
       </p:sp>
       <p:sp>
         <p:nvSpPr>
@@ -11453,6 +11625,10 @@
             <a:prstDash val="solid"/>
           </a:ln>
         </p:spPr>
+        <p:txBody>
+          <a:bodyPr/>
+          <a:p/>
+        </p:txBody>
       </p:sp>
       <p:sp>
         <p:nvSpPr>
@@ -11478,6 +11654,10 @@
             <a:prstDash val="solid"/>
           </a:ln>
         </p:spPr>
+        <p:txBody>
+          <a:bodyPr/>
+          <a:p/>
+        </p:txBody>
       </p:sp>
       <p:sp>
         <p:nvSpPr>
@@ -11620,6 +11800,10 @@
             <a:prstDash val="solid"/>
           </a:ln>
         </p:spPr>
+        <p:txBody>
+          <a:bodyPr/>
+          <a:p/>
+        </p:txBody>
       </p:sp>
       <p:sp>
         <p:nvSpPr>
@@ -11645,6 +11829,10 @@
             <a:prstDash val="solid"/>
           </a:ln>
         </p:spPr>
+        <p:txBody>
+          <a:bodyPr/>
+          <a:p/>
+        </p:txBody>
       </p:sp>
       <p:sp>
         <p:nvSpPr>
@@ -11787,6 +11975,10 @@
             <a:prstDash val="solid"/>
           </a:ln>
         </p:spPr>
+        <p:txBody>
+          <a:bodyPr/>
+          <a:p/>
+        </p:txBody>
       </p:sp>
       <p:sp>
         <p:nvSpPr>
@@ -11812,6 +12004,10 @@
             <a:prstDash val="solid"/>
           </a:ln>
         </p:spPr>
+        <p:txBody>
+          <a:bodyPr/>
+          <a:p/>
+        </p:txBody>
       </p:sp>
       <p:sp>
         <p:nvSpPr>
@@ -11954,6 +12150,10 @@
             <a:prstDash val="solid"/>
           </a:ln>
         </p:spPr>
+        <p:txBody>
+          <a:bodyPr/>
+          <a:p/>
+        </p:txBody>
       </p:sp>
       <p:sp>
         <p:nvSpPr>
@@ -11979,6 +12179,10 @@
             <a:prstDash val="solid"/>
           </a:ln>
         </p:spPr>
+        <p:txBody>
+          <a:bodyPr/>
+          <a:p/>
+        </p:txBody>
       </p:sp>
       <p:sp>
         <p:nvSpPr>
@@ -12169,7 +12373,7 @@
                 <a:ea typeface="Calibri" pitchFamily="34" charset="-122"/>
                 <a:cs typeface="Calibri" pitchFamily="34" charset="-120"/>
               </a:rPr>
-              <a:t>GSE Foreclosure Analysis  |  ServiceLink  |  April 2026</a:t>
+              <a:t>GSE Foreclosure Analysis  |  April 2026</a:t>
             </a:r>
             <a:endParaRPr lang="en-US" sz="1000" dirty="0"/>
           </a:p>
@@ -12307,6 +12511,10 @@
             <a:prstDash val="solid"/>
           </a:ln>
         </p:spPr>
+        <p:txBody>
+          <a:bodyPr/>
+          <a:p/>
+        </p:txBody>
       </p:sp>
       <p:pic>
         <p:nvPicPr>
@@ -12501,6 +12709,10 @@
             <a:prstDash val="solid"/>
           </a:ln>
         </p:spPr>
+        <p:txBody>
+          <a:bodyPr/>
+          <a:p/>
+        </p:txBody>
       </p:sp>
       <p:sp>
         <p:nvSpPr>
@@ -12641,7 +12853,7 @@
                 <a:ea typeface="Calibri" pitchFamily="34" charset="-122"/>
                 <a:cs typeface="Calibri" pitchFamily="34" charset="-120"/>
               </a:rPr>
-              <a:t>GSE Foreclosure Analysis  |  ServiceLink  |  April 2026</a:t>
+              <a:t>GSE Foreclosure Analysis  |  April 2026</a:t>
             </a:r>
             <a:endParaRPr lang="en-US" sz="1000" dirty="0"/>
           </a:p>
@@ -12779,6 +12991,10 @@
             <a:prstDash val="solid"/>
           </a:ln>
         </p:spPr>
+        <p:txBody>
+          <a:bodyPr/>
+          <a:p/>
+        </p:txBody>
       </p:sp>
       <p:pic>
         <p:nvPicPr>
@@ -13500,7 +13716,7 @@
                 <a:ea typeface="Calibri" pitchFamily="34" charset="-122"/>
                 <a:cs typeface="Calibri" pitchFamily="34" charset="-120"/>
               </a:rPr>
-              <a:t>GSE Foreclosure Analysis  |  ServiceLink  |  April 2026</a:t>
+              <a:t>GSE Foreclosure Analysis  |  April 2026</a:t>
             </a:r>
             <a:endParaRPr lang="en-US" sz="1000" dirty="0"/>
           </a:p>
@@ -13638,6 +13854,10 @@
             <a:prstDash val="solid"/>
           </a:ln>
         </p:spPr>
+        <p:txBody>
+          <a:bodyPr/>
+          <a:p/>
+        </p:txBody>
       </p:sp>
       <p:pic>
         <p:nvPicPr>
@@ -13726,6 +13946,10 @@
             <a:prstDash val="solid"/>
           </a:ln>
         </p:spPr>
+        <p:txBody>
+          <a:bodyPr/>
+          <a:p/>
+        </p:txBody>
       </p:sp>
       <p:sp>
         <p:nvSpPr>
@@ -13829,6 +14053,10 @@
             <a:prstDash val="solid"/>
           </a:ln>
         </p:spPr>
+        <p:txBody>
+          <a:bodyPr/>
+          <a:p/>
+        </p:txBody>
       </p:sp>
       <p:sp>
         <p:nvSpPr>
@@ -13932,6 +14160,10 @@
             <a:prstDash val="solid"/>
           </a:ln>
         </p:spPr>
+        <p:txBody>
+          <a:bodyPr/>
+          <a:p/>
+        </p:txBody>
       </p:sp>
       <p:sp>
         <p:nvSpPr>
@@ -14035,6 +14267,10 @@
             <a:prstDash val="solid"/>
           </a:ln>
         </p:spPr>
+        <p:txBody>
+          <a:bodyPr/>
+          <a:p/>
+        </p:txBody>
       </p:sp>
       <p:sp>
         <p:nvSpPr>
@@ -14161,7 +14397,7 @@
                 <a:ea typeface="Calibri" pitchFamily="34" charset="-122"/>
                 <a:cs typeface="Calibri" pitchFamily="34" charset="-120"/>
               </a:rPr>
-              <a:t>GSE Foreclosure Analysis  |  ServiceLink  |  April 2026</a:t>
+              <a:t>GSE Foreclosure Analysis  |  April 2026</a:t>
             </a:r>
             <a:endParaRPr lang="en-US" sz="1000" dirty="0"/>
           </a:p>
@@ -14299,6 +14535,10 @@
             <a:prstDash val="solid"/>
           </a:ln>
         </p:spPr>
+        <p:txBody>
+          <a:bodyPr/>
+          <a:p/>
+        </p:txBody>
       </p:sp>
       <p:sp>
         <p:nvSpPr>
@@ -14426,6 +14666,10 @@
             <a:prstDash val="solid"/>
           </a:ln>
         </p:spPr>
+        <p:txBody>
+          <a:bodyPr/>
+          <a:p/>
+        </p:txBody>
       </p:sp>
       <p:sp>
         <p:nvSpPr>
@@ -14552,7 +14796,7 @@
                 <a:ea typeface="Calibri" pitchFamily="34" charset="-122"/>
                 <a:cs typeface="Calibri" pitchFamily="34" charset="-120"/>
               </a:rPr>
-              <a:t>GSE Foreclosure Analysis  |  ServiceLink  |  April 2026</a:t>
+              <a:t>GSE Foreclosure Analysis  |  April 2026</a:t>
             </a:r>
             <a:endParaRPr lang="en-US" sz="1000" dirty="0"/>
           </a:p>

</xml_diff>